<commit_message>
lecture ready (0821) : TS_with react
</commit_message>
<xml_diff>
--- a/material/[SeSAC_YDP_6] 33_TypeScript_with_React.pptx
+++ b/material/[SeSAC_YDP_6] 33_TypeScript_with_React.pptx
@@ -2,10 +2,10 @@
 <file path=ppt/presentation.xml><?xml version="1.0" encoding="utf-8"?>
 <p:presentation xmlns:a="http://schemas.openxmlformats.org/drawingml/2006/main" xmlns:r="http://schemas.openxmlformats.org/officeDocument/2006/relationships" xmlns:p="http://schemas.openxmlformats.org/presentationml/2006/main" embedTrueTypeFonts="1" saveSubsetFonts="1">
   <p:sldMasterIdLst>
-    <p:sldMasterId id="2147483660" r:id="rId1"/>
+    <p:sldMasterId id="2147483673" r:id="rId1"/>
   </p:sldMasterIdLst>
   <p:notesMasterIdLst>
-    <p:notesMasterId r:id="rId11"/>
+    <p:notesMasterId r:id="rId12"/>
   </p:notesMasterIdLst>
   <p:sldIdLst>
     <p:sldId id="649" r:id="rId2"/>
@@ -17,26 +17,32 @@
     <p:sldId id="296" r:id="rId8"/>
     <p:sldId id="297" r:id="rId9"/>
     <p:sldId id="298" r:id="rId10"/>
+    <p:sldId id="662" r:id="rId11"/>
   </p:sldIdLst>
   <p:sldSz cx="12192000" cy="6858000"/>
   <p:notesSz cx="6858000" cy="9144000"/>
   <p:embeddedFontLst>
     <p:embeddedFont>
-      <p:font typeface="메이플스토리" panose="020B0600000101010101" charset="-127"/>
-      <p:regular r:id="rId12"/>
-      <p:bold r:id="rId13"/>
+      <p:font typeface="Pretendard GOV" panose="02000503000000020004" pitchFamily="2" charset="-127"/>
+      <p:regular r:id="rId13"/>
+      <p:bold r:id="rId14"/>
     </p:embeddedFont>
     <p:embeddedFont>
-      <p:font typeface="Cascadia Code SemiLight" panose="020B0600000101010101" charset="0"/>
-      <p:regular r:id="rId14"/>
-      <p:italic r:id="rId15"/>
+      <p:font typeface="메이플스토리" panose="020B0600000101010101" charset="-127"/>
+      <p:regular r:id="rId15"/>
+      <p:bold r:id="rId16"/>
+    </p:embeddedFont>
+    <p:embeddedFont>
+      <p:font typeface="Cascadia Code SemiLight" panose="020B0609020000020004" pitchFamily="49" charset="0"/>
+      <p:regular r:id="rId17"/>
+      <p:italic r:id="rId18"/>
     </p:embeddedFont>
     <p:embeddedFont>
       <p:font typeface="Consolas" panose="020B0609020204030204" pitchFamily="49" charset="0"/>
-      <p:regular r:id="rId16"/>
-      <p:bold r:id="rId17"/>
-      <p:italic r:id="rId18"/>
-      <p:boldItalic r:id="rId19"/>
+      <p:regular r:id="rId19"/>
+      <p:bold r:id="rId20"/>
+      <p:italic r:id="rId21"/>
+      <p:boldItalic r:id="rId22"/>
     </p:embeddedFont>
   </p:embeddedFontLst>
   <p:defaultTextStyle>
@@ -231,7 +237,7 @@
             <a:fld id="{FCB54652-048B-4930-89EC-2DB9C4976659}" type="datetimeFigureOut">
               <a:rPr lang="ko-KR" altLang="en-US" smtClean="0"/>
               <a:pPr/>
-              <a:t>2023-10-19</a:t>
+              <a:t>2024-08-21</a:t>
             </a:fld>
             <a:endParaRPr lang="ko-KR" altLang="en-US" dirty="0"/>
           </a:p>
@@ -842,14 +848,10 @@
             </a:r>
             <a:r>
               <a:rPr lang="ko-KR" altLang="en-US" dirty="0"/>
-              <a:t>로 설정하는 </a:t>
-            </a:r>
-            <a:r>
-              <a:rPr lang="ko-KR" altLang="en-US"/>
-              <a:t>경우에는 </a:t>
-            </a:r>
-            <a:r>
-              <a:rPr lang="en-US" altLang="ko-KR"/>
+              <a:t>로 설정하는 경우에는 </a:t>
+            </a:r>
+            <a:r>
+              <a:rPr lang="en-US" altLang="ko-KR" dirty="0"/>
               <a:t>typescript</a:t>
             </a:r>
             <a:r>
@@ -1075,6 +1077,302 @@
 </p:notes>
 </file>
 
+<file path=ppt/notesSlides/notesSlide6.xml><?xml version="1.0" encoding="utf-8"?>
+<p:notes xmlns:a="http://schemas.openxmlformats.org/drawingml/2006/main" xmlns:r="http://schemas.openxmlformats.org/officeDocument/2006/relationships" xmlns:p="http://schemas.openxmlformats.org/presentationml/2006/main">
+  <p:cSld>
+    <p:spTree>
+      <p:nvGrpSpPr>
+        <p:cNvPr id="1" name=""/>
+        <p:cNvGrpSpPr/>
+        <p:nvPr/>
+      </p:nvGrpSpPr>
+      <p:grpSpPr>
+        <a:xfrm>
+          <a:off x="0" y="0"/>
+          <a:ext cx="0" cy="0"/>
+          <a:chOff x="0" y="0"/>
+          <a:chExt cx="0" cy="0"/>
+        </a:xfrm>
+      </p:grpSpPr>
+      <p:sp>
+        <p:nvSpPr>
+          <p:cNvPr id="2" name="슬라이드 이미지 개체 틀 1"/>
+          <p:cNvSpPr>
+            <a:spLocks noGrp="1" noRot="1" noChangeAspect="1"/>
+          </p:cNvSpPr>
+          <p:nvPr>
+            <p:ph type="sldImg"/>
+          </p:nvPr>
+        </p:nvSpPr>
+        <p:spPr/>
+      </p:sp>
+      <p:sp>
+        <p:nvSpPr>
+          <p:cNvPr id="3" name="슬라이드 노트 개체 틀 2"/>
+          <p:cNvSpPr>
+            <a:spLocks noGrp="1"/>
+          </p:cNvSpPr>
+          <p:nvPr>
+            <p:ph type="body" idx="1"/>
+          </p:nvPr>
+        </p:nvSpPr>
+        <p:spPr/>
+        <p:txBody>
+          <a:bodyPr/>
+          <a:lstStyle/>
+          <a:p>
+            <a:endParaRPr lang="ko-KR" altLang="en-US" dirty="0"/>
+          </a:p>
+        </p:txBody>
+      </p:sp>
+      <p:sp>
+        <p:nvSpPr>
+          <p:cNvPr id="4" name="슬라이드 번호 개체 틀 3"/>
+          <p:cNvSpPr>
+            <a:spLocks noGrp="1"/>
+          </p:cNvSpPr>
+          <p:nvPr>
+            <p:ph type="sldNum" sz="quarter" idx="5"/>
+          </p:nvPr>
+        </p:nvSpPr>
+        <p:spPr/>
+        <p:txBody>
+          <a:bodyPr/>
+          <a:lstStyle/>
+          <a:p>
+            <a:fld id="{E36974B4-3C72-4F7B-BD8B-CF478B248459}" type="slidenum">
+              <a:rPr lang="ko-KR" altLang="en-US" smtClean="0"/>
+              <a:pPr/>
+              <a:t>8</a:t>
+            </a:fld>
+            <a:endParaRPr lang="ko-KR" altLang="en-US" dirty="0"/>
+          </a:p>
+        </p:txBody>
+      </p:sp>
+    </p:spTree>
+    <p:extLst>
+      <p:ext uri="{BB962C8B-B14F-4D97-AF65-F5344CB8AC3E}">
+        <p14:creationId xmlns:p14="http://schemas.microsoft.com/office/powerpoint/2010/main" val="2475667731"/>
+      </p:ext>
+    </p:extLst>
+  </p:cSld>
+  <p:clrMapOvr>
+    <a:masterClrMapping/>
+  </p:clrMapOvr>
+</p:notes>
+</file>
+
+<file path=ppt/notesSlides/notesSlide7.xml><?xml version="1.0" encoding="utf-8"?>
+<p:notes xmlns:a="http://schemas.openxmlformats.org/drawingml/2006/main" xmlns:r="http://schemas.openxmlformats.org/officeDocument/2006/relationships" xmlns:p="http://schemas.openxmlformats.org/presentationml/2006/main">
+  <p:cSld>
+    <p:spTree>
+      <p:nvGrpSpPr>
+        <p:cNvPr id="1" name=""/>
+        <p:cNvGrpSpPr/>
+        <p:nvPr/>
+      </p:nvGrpSpPr>
+      <p:grpSpPr>
+        <a:xfrm>
+          <a:off x="0" y="0"/>
+          <a:ext cx="0" cy="0"/>
+          <a:chOff x="0" y="0"/>
+          <a:chExt cx="0" cy="0"/>
+        </a:xfrm>
+      </p:grpSpPr>
+      <p:sp>
+        <p:nvSpPr>
+          <p:cNvPr id="2" name="슬라이드 이미지 개체 틀 1"/>
+          <p:cNvSpPr>
+            <a:spLocks noGrp="1" noRot="1" noChangeAspect="1"/>
+          </p:cNvSpPr>
+          <p:nvPr>
+            <p:ph type="sldImg"/>
+          </p:nvPr>
+        </p:nvSpPr>
+        <p:spPr/>
+      </p:sp>
+      <p:sp>
+        <p:nvSpPr>
+          <p:cNvPr id="3" name="슬라이드 노트 개체 틀 2"/>
+          <p:cNvSpPr>
+            <a:spLocks noGrp="1"/>
+          </p:cNvSpPr>
+          <p:nvPr>
+            <p:ph type="body" idx="1"/>
+          </p:nvPr>
+        </p:nvSpPr>
+        <p:spPr/>
+        <p:txBody>
+          <a:bodyPr/>
+          <a:lstStyle/>
+          <a:p>
+            <a:pPr marL="0" marR="0" lvl="0" indent="0" algn="l" defTabSz="914400" rtl="0" eaLnBrk="1" fontAlgn="auto" latinLnBrk="1" hangingPunct="1">
+              <a:lnSpc>
+                <a:spcPct val="100000"/>
+              </a:lnSpc>
+              <a:spcBef>
+                <a:spcPts val="0"/>
+              </a:spcBef>
+              <a:spcAft>
+                <a:spcPts val="0"/>
+              </a:spcAft>
+              <a:buClrTx/>
+              <a:buSzTx/>
+              <a:buFontTx/>
+              <a:buNone/>
+              <a:tabLst/>
+              <a:defRPr/>
+            </a:pPr>
+            <a:r>
+              <a:rPr lang="en-US" altLang="ko-KR" b="0" dirty="0">
+                <a:solidFill>
+                  <a:srgbClr val="6A9955"/>
+                </a:solidFill>
+                <a:effectLst/>
+                <a:highlight>
+                  <a:srgbClr val="1F1F1F"/>
+                </a:highlight>
+                <a:latin typeface="Consolas" panose="020B0609020204030204" pitchFamily="49" charset="0"/>
+              </a:rPr>
+              <a:t>https://react-typescript-cheatsheet.netlify.app/</a:t>
+            </a:r>
+            <a:endParaRPr lang="en-US" altLang="ko-KR" b="0" dirty="0">
+              <a:solidFill>
+                <a:srgbClr val="CCCCCC"/>
+              </a:solidFill>
+              <a:effectLst/>
+              <a:highlight>
+                <a:srgbClr val="1F1F1F"/>
+              </a:highlight>
+              <a:latin typeface="Consolas" panose="020B0609020204030204" pitchFamily="49" charset="0"/>
+            </a:endParaRPr>
+          </a:p>
+          <a:p>
+            <a:endParaRPr lang="ko-KR" altLang="en-US" dirty="0"/>
+          </a:p>
+        </p:txBody>
+      </p:sp>
+      <p:sp>
+        <p:nvSpPr>
+          <p:cNvPr id="4" name="슬라이드 번호 개체 틀 3"/>
+          <p:cNvSpPr>
+            <a:spLocks noGrp="1"/>
+          </p:cNvSpPr>
+          <p:nvPr>
+            <p:ph type="sldNum" sz="quarter" idx="5"/>
+          </p:nvPr>
+        </p:nvSpPr>
+        <p:spPr/>
+        <p:txBody>
+          <a:bodyPr/>
+          <a:lstStyle/>
+          <a:p>
+            <a:fld id="{E36974B4-3C72-4F7B-BD8B-CF478B248459}" type="slidenum">
+              <a:rPr lang="ko-KR" altLang="en-US" smtClean="0"/>
+              <a:pPr/>
+              <a:t>9</a:t>
+            </a:fld>
+            <a:endParaRPr lang="ko-KR" altLang="en-US" dirty="0"/>
+          </a:p>
+        </p:txBody>
+      </p:sp>
+    </p:spTree>
+    <p:extLst>
+      <p:ext uri="{BB962C8B-B14F-4D97-AF65-F5344CB8AC3E}">
+        <p14:creationId xmlns:p14="http://schemas.microsoft.com/office/powerpoint/2010/main" val="4033561890"/>
+      </p:ext>
+    </p:extLst>
+  </p:cSld>
+  <p:clrMapOvr>
+    <a:masterClrMapping/>
+  </p:clrMapOvr>
+</p:notes>
+</file>
+
+<file path=ppt/notesSlides/notesSlide8.xml><?xml version="1.0" encoding="utf-8"?>
+<p:notes xmlns:a="http://schemas.openxmlformats.org/drawingml/2006/main" xmlns:r="http://schemas.openxmlformats.org/officeDocument/2006/relationships" xmlns:p="http://schemas.openxmlformats.org/presentationml/2006/main">
+  <p:cSld>
+    <p:spTree>
+      <p:nvGrpSpPr>
+        <p:cNvPr id="1" name=""/>
+        <p:cNvGrpSpPr/>
+        <p:nvPr/>
+      </p:nvGrpSpPr>
+      <p:grpSpPr>
+        <a:xfrm>
+          <a:off x="0" y="0"/>
+          <a:ext cx="0" cy="0"/>
+          <a:chOff x="0" y="0"/>
+          <a:chExt cx="0" cy="0"/>
+        </a:xfrm>
+      </p:grpSpPr>
+      <p:sp>
+        <p:nvSpPr>
+          <p:cNvPr id="2" name="슬라이드 이미지 개체 틀 1"/>
+          <p:cNvSpPr>
+            <a:spLocks noGrp="1" noRot="1" noChangeAspect="1"/>
+          </p:cNvSpPr>
+          <p:nvPr>
+            <p:ph type="sldImg"/>
+          </p:nvPr>
+        </p:nvSpPr>
+        <p:spPr/>
+      </p:sp>
+      <p:sp>
+        <p:nvSpPr>
+          <p:cNvPr id="3" name="슬라이드 노트 개체 틀 2"/>
+          <p:cNvSpPr>
+            <a:spLocks noGrp="1"/>
+          </p:cNvSpPr>
+          <p:nvPr>
+            <p:ph type="body" idx="1"/>
+          </p:nvPr>
+        </p:nvSpPr>
+        <p:spPr/>
+        <p:txBody>
+          <a:bodyPr/>
+          <a:lstStyle/>
+          <a:p>
+            <a:endParaRPr lang="en-US" altLang="ko-KR" dirty="0"/>
+          </a:p>
+        </p:txBody>
+      </p:sp>
+      <p:sp>
+        <p:nvSpPr>
+          <p:cNvPr id="4" name="슬라이드 번호 개체 틀 3"/>
+          <p:cNvSpPr>
+            <a:spLocks noGrp="1"/>
+          </p:cNvSpPr>
+          <p:nvPr>
+            <p:ph type="sldNum" sz="quarter" idx="5"/>
+          </p:nvPr>
+        </p:nvSpPr>
+        <p:spPr/>
+        <p:txBody>
+          <a:bodyPr/>
+          <a:lstStyle/>
+          <a:p>
+            <a:fld id="{C09E5BFC-1559-42F1-8940-AB342D56BF02}" type="slidenum">
+              <a:rPr lang="ko-KR" altLang="en-US" smtClean="0"/>
+              <a:t>10</a:t>
+            </a:fld>
+            <a:endParaRPr lang="ko-KR" altLang="en-US"/>
+          </a:p>
+        </p:txBody>
+      </p:sp>
+    </p:spTree>
+    <p:extLst>
+      <p:ext uri="{BB962C8B-B14F-4D97-AF65-F5344CB8AC3E}">
+        <p14:creationId xmlns:p14="http://schemas.microsoft.com/office/powerpoint/2010/main" val="2415502920"/>
+      </p:ext>
+    </p:extLst>
+  </p:cSld>
+  <p:clrMapOvr>
+    <a:masterClrMapping/>
+  </p:clrMapOvr>
+</p:notes>
+</file>
+
 <file path=ppt/slideLayouts/slideLayout1.xml><?xml version="1.0" encoding="utf-8"?>
 <p:sldLayout xmlns:a="http://schemas.openxmlformats.org/drawingml/2006/main" xmlns:r="http://schemas.openxmlformats.org/officeDocument/2006/relationships" xmlns:p="http://schemas.openxmlformats.org/presentationml/2006/main" type="title" preserve="1">
   <p:cSld name="제목 슬라이드">
@@ -1092,43 +1390,6 @@
           <a:chExt cx="0" cy="0"/>
         </a:xfrm>
       </p:grpSpPr>
-      <p:pic>
-        <p:nvPicPr>
-          <p:cNvPr id="7" name="그림 6" descr="폰트, 텍스트, 로고, 그래픽이(가) 표시된 사진&#10;&#10;자동 생성된 설명">
-            <a:extLst>
-              <a:ext uri="{FF2B5EF4-FFF2-40B4-BE49-F238E27FC236}">
-                <a16:creationId xmlns:a16="http://schemas.microsoft.com/office/drawing/2014/main" id="{01AB1409-DEDF-C824-D8D3-05B260A93BD6}"/>
-              </a:ext>
-            </a:extLst>
-          </p:cNvPr>
-          <p:cNvPicPr>
-            <a:picLocks noChangeAspect="1"/>
-          </p:cNvPicPr>
-          <p:nvPr userDrawn="1"/>
-        </p:nvPicPr>
-        <p:blipFill>
-          <a:blip r:embed="rId2">
-            <a:alphaModFix/>
-            <a:extLst>
-              <a:ext uri="{28A0092B-C50C-407E-A947-70E740481C1C}">
-                <a14:useLocalDpi xmlns:a14="http://schemas.microsoft.com/office/drawing/2010/main" val="0"/>
-              </a:ext>
-            </a:extLst>
-          </a:blip>
-          <a:stretch>
-            <a:fillRect/>
-          </a:stretch>
-        </p:blipFill>
-        <p:spPr>
-          <a:xfrm>
-            <a:off x="118533" y="103811"/>
-            <a:ext cx="4328535" cy="2280805"/>
-          </a:xfrm>
-          <a:prstGeom prst="rect">
-            <a:avLst/>
-          </a:prstGeom>
-        </p:spPr>
-      </p:pic>
       <p:sp>
         <p:nvSpPr>
           <p:cNvPr id="2" name="제목 1">
@@ -1266,7 +1527,7 @@
           <a:p>
             <a:fld id="{0E19CB95-6D28-40F1-9DA3-1BAC5D4B5B4F}" type="datetime6">
               <a:rPr lang="ko-KR" altLang="en-US" smtClean="0"/>
-              <a:t>2023년 10월</a:t>
+              <a:t>2024년 8월</a:t>
             </a:fld>
             <a:endParaRPr lang="ko-KR" altLang="en-US"/>
           </a:p>
@@ -1381,221 +1642,47 @@
           </a:p>
         </p:txBody>
       </p:sp>
-      <p:sp>
-        <p:nvSpPr>
-          <p:cNvPr id="15" name="부제목 2">
+      <p:pic>
+        <p:nvPicPr>
+          <p:cNvPr id="5" name="그림 4" descr="그래픽, 그래픽 디자인, 클립아트, 다채로움이(가) 표시된 사진&#10;&#10;자동 생성된 설명">
             <a:extLst>
               <a:ext uri="{FF2B5EF4-FFF2-40B4-BE49-F238E27FC236}">
-                <a16:creationId xmlns:a16="http://schemas.microsoft.com/office/drawing/2014/main" id="{26026682-DE15-5F01-6FA7-8F46F9ABCC2A}"/>
+                <a16:creationId xmlns:a16="http://schemas.microsoft.com/office/drawing/2014/main" id="{BE5A577B-81A7-2FA6-9E57-9DCEC5BF71F7}"/>
               </a:ext>
             </a:extLst>
           </p:cNvPr>
-          <p:cNvSpPr txBox="1">
-            <a:spLocks/>
-          </p:cNvSpPr>
+          <p:cNvPicPr>
+            <a:picLocks noChangeAspect="1"/>
+          </p:cNvPicPr>
           <p:nvPr userDrawn="1"/>
-        </p:nvSpPr>
+        </p:nvPicPr>
+        <p:blipFill>
+          <a:blip r:embed="rId2">
+            <a:alphaModFix amt="20000"/>
+            <a:extLst>
+              <a:ext uri="{28A0092B-C50C-407E-A947-70E740481C1C}">
+                <a14:useLocalDpi xmlns:a14="http://schemas.microsoft.com/office/drawing/2010/main" val="0"/>
+              </a:ext>
+            </a:extLst>
+          </a:blip>
+          <a:stretch>
+            <a:fillRect/>
+          </a:stretch>
+        </p:blipFill>
         <p:spPr>
           <a:xfrm>
-            <a:off x="9110749" y="5933035"/>
-            <a:ext cx="2948515" cy="365125"/>
+            <a:off x="4296000" y="1461146"/>
+            <a:ext cx="3600000" cy="3652155"/>
           </a:xfrm>
           <a:prstGeom prst="rect">
             <a:avLst/>
           </a:prstGeom>
         </p:spPr>
-        <p:txBody>
-          <a:bodyPr vert="horz" lIns="91440" tIns="45720" rIns="91440" bIns="45720" rtlCol="0" anchor="ctr">
-            <a:noAutofit/>
-          </a:bodyPr>
-          <a:lstStyle>
-            <a:lvl1pPr marL="228600" indent="-228600" algn="l" defTabSz="914400" rtl="0" eaLnBrk="1" latinLnBrk="1" hangingPunct="1">
-              <a:lnSpc>
-                <a:spcPct val="90000"/>
-              </a:lnSpc>
-              <a:spcBef>
-                <a:spcPts val="1000"/>
-              </a:spcBef>
-              <a:buFont typeface="Arial" panose="020B0604020202020204" pitchFamily="34" charset="0"/>
-              <a:buChar char="•"/>
-              <a:defRPr sz="2800" kern="1200">
-                <a:solidFill>
-                  <a:schemeClr val="tx1"/>
-                </a:solidFill>
-                <a:latin typeface="+mn-lt"/>
-                <a:ea typeface="+mn-ea"/>
-                <a:cs typeface="+mn-cs"/>
-              </a:defRPr>
-            </a:lvl1pPr>
-            <a:lvl2pPr marL="685800" indent="-228600" algn="l" defTabSz="914400" rtl="0" eaLnBrk="1" latinLnBrk="1" hangingPunct="1">
-              <a:lnSpc>
-                <a:spcPct val="90000"/>
-              </a:lnSpc>
-              <a:spcBef>
-                <a:spcPts val="500"/>
-              </a:spcBef>
-              <a:buFont typeface="Arial" panose="020B0604020202020204" pitchFamily="34" charset="0"/>
-              <a:buChar char="•"/>
-              <a:defRPr sz="2400" kern="1200">
-                <a:solidFill>
-                  <a:schemeClr val="tx1"/>
-                </a:solidFill>
-                <a:latin typeface="+mn-lt"/>
-                <a:ea typeface="+mn-ea"/>
-                <a:cs typeface="+mn-cs"/>
-              </a:defRPr>
-            </a:lvl2pPr>
-            <a:lvl3pPr marL="1143000" indent="-228600" algn="l" defTabSz="914400" rtl="0" eaLnBrk="1" latinLnBrk="1" hangingPunct="1">
-              <a:lnSpc>
-                <a:spcPct val="90000"/>
-              </a:lnSpc>
-              <a:spcBef>
-                <a:spcPts val="500"/>
-              </a:spcBef>
-              <a:buFont typeface="Arial" panose="020B0604020202020204" pitchFamily="34" charset="0"/>
-              <a:buChar char="•"/>
-              <a:defRPr sz="2000" kern="1200">
-                <a:solidFill>
-                  <a:schemeClr val="tx1"/>
-                </a:solidFill>
-                <a:latin typeface="+mn-lt"/>
-                <a:ea typeface="+mn-ea"/>
-                <a:cs typeface="+mn-cs"/>
-              </a:defRPr>
-            </a:lvl3pPr>
-            <a:lvl4pPr marL="1600200" indent="-228600" algn="l" defTabSz="914400" rtl="0" eaLnBrk="1" latinLnBrk="1" hangingPunct="1">
-              <a:lnSpc>
-                <a:spcPct val="90000"/>
-              </a:lnSpc>
-              <a:spcBef>
-                <a:spcPts val="500"/>
-              </a:spcBef>
-              <a:buFont typeface="Arial" panose="020B0604020202020204" pitchFamily="34" charset="0"/>
-              <a:buChar char="•"/>
-              <a:defRPr sz="1800" kern="1200">
-                <a:solidFill>
-                  <a:schemeClr val="tx1"/>
-                </a:solidFill>
-                <a:latin typeface="+mn-lt"/>
-                <a:ea typeface="+mn-ea"/>
-                <a:cs typeface="+mn-cs"/>
-              </a:defRPr>
-            </a:lvl4pPr>
-            <a:lvl5pPr marL="2057400" indent="-228600" algn="l" defTabSz="914400" rtl="0" eaLnBrk="1" latinLnBrk="1" hangingPunct="1">
-              <a:lnSpc>
-                <a:spcPct val="90000"/>
-              </a:lnSpc>
-              <a:spcBef>
-                <a:spcPts val="500"/>
-              </a:spcBef>
-              <a:buFont typeface="Arial" panose="020B0604020202020204" pitchFamily="34" charset="0"/>
-              <a:buChar char="•"/>
-              <a:defRPr sz="1800" kern="1200">
-                <a:solidFill>
-                  <a:schemeClr val="tx1"/>
-                </a:solidFill>
-                <a:latin typeface="+mn-lt"/>
-                <a:ea typeface="+mn-ea"/>
-                <a:cs typeface="+mn-cs"/>
-              </a:defRPr>
-            </a:lvl5pPr>
-            <a:lvl6pPr marL="2514600" indent="-228600" algn="l" defTabSz="914400" rtl="0" eaLnBrk="1" latinLnBrk="1" hangingPunct="1">
-              <a:lnSpc>
-                <a:spcPct val="90000"/>
-              </a:lnSpc>
-              <a:spcBef>
-                <a:spcPts val="500"/>
-              </a:spcBef>
-              <a:buFont typeface="Arial" panose="020B0604020202020204" pitchFamily="34" charset="0"/>
-              <a:buChar char="•"/>
-              <a:defRPr sz="1800" kern="1200">
-                <a:solidFill>
-                  <a:schemeClr val="tx1"/>
-                </a:solidFill>
-                <a:latin typeface="+mn-lt"/>
-                <a:ea typeface="+mn-ea"/>
-                <a:cs typeface="+mn-cs"/>
-              </a:defRPr>
-            </a:lvl6pPr>
-            <a:lvl7pPr marL="2971800" indent="-228600" algn="l" defTabSz="914400" rtl="0" eaLnBrk="1" latinLnBrk="1" hangingPunct="1">
-              <a:lnSpc>
-                <a:spcPct val="90000"/>
-              </a:lnSpc>
-              <a:spcBef>
-                <a:spcPts val="500"/>
-              </a:spcBef>
-              <a:buFont typeface="Arial" panose="020B0604020202020204" pitchFamily="34" charset="0"/>
-              <a:buChar char="•"/>
-              <a:defRPr sz="1800" kern="1200">
-                <a:solidFill>
-                  <a:schemeClr val="tx1"/>
-                </a:solidFill>
-                <a:latin typeface="+mn-lt"/>
-                <a:ea typeface="+mn-ea"/>
-                <a:cs typeface="+mn-cs"/>
-              </a:defRPr>
-            </a:lvl7pPr>
-            <a:lvl8pPr marL="3429000" indent="-228600" algn="l" defTabSz="914400" rtl="0" eaLnBrk="1" latinLnBrk="1" hangingPunct="1">
-              <a:lnSpc>
-                <a:spcPct val="90000"/>
-              </a:lnSpc>
-              <a:spcBef>
-                <a:spcPts val="500"/>
-              </a:spcBef>
-              <a:buFont typeface="Arial" panose="020B0604020202020204" pitchFamily="34" charset="0"/>
-              <a:buChar char="•"/>
-              <a:defRPr sz="1800" kern="1200">
-                <a:solidFill>
-                  <a:schemeClr val="tx1"/>
-                </a:solidFill>
-                <a:latin typeface="+mn-lt"/>
-                <a:ea typeface="+mn-ea"/>
-                <a:cs typeface="+mn-cs"/>
-              </a:defRPr>
-            </a:lvl8pPr>
-            <a:lvl9pPr marL="3886200" indent="-228600" algn="l" defTabSz="914400" rtl="0" eaLnBrk="1" latinLnBrk="1" hangingPunct="1">
-              <a:lnSpc>
-                <a:spcPct val="90000"/>
-              </a:lnSpc>
-              <a:spcBef>
-                <a:spcPts val="500"/>
-              </a:spcBef>
-              <a:buFont typeface="Arial" panose="020B0604020202020204" pitchFamily="34" charset="0"/>
-              <a:buChar char="•"/>
-              <a:defRPr sz="1800" kern="1200">
-                <a:solidFill>
-                  <a:schemeClr val="tx1"/>
-                </a:solidFill>
-                <a:latin typeface="+mn-lt"/>
-                <a:ea typeface="+mn-ea"/>
-                <a:cs typeface="+mn-cs"/>
-              </a:defRPr>
-            </a:lvl9pPr>
-          </a:lstStyle>
-          <a:p>
-            <a:pPr marL="0" indent="0" algn="r">
-              <a:buNone/>
-            </a:pPr>
-            <a:r>
-              <a:rPr lang="en-US" altLang="ko-KR" sz="2000" u="none" dirty="0"/>
-              <a:t>With. </a:t>
-            </a:r>
-            <a:r>
-              <a:rPr lang="ko-KR" altLang="en-US" sz="2000" u="none" dirty="0"/>
-              <a:t>팀 </a:t>
-            </a:r>
-            <a:r>
-              <a:rPr lang="ko-KR" altLang="en-US" sz="2000" u="none" dirty="0" err="1"/>
-              <a:t>뤼쳐드</a:t>
-            </a:r>
-            <a:endParaRPr lang="ko-KR" altLang="en-US" sz="2000" u="none" dirty="0"/>
-          </a:p>
-        </p:txBody>
-      </p:sp>
+      </p:pic>
     </p:spTree>
     <p:extLst>
       <p:ext uri="{BB962C8B-B14F-4D97-AF65-F5344CB8AC3E}">
-        <p14:creationId xmlns:p14="http://schemas.microsoft.com/office/powerpoint/2010/main" val="1322938533"/>
+        <p14:creationId xmlns:p14="http://schemas.microsoft.com/office/powerpoint/2010/main" val="2906070268"/>
       </p:ext>
     </p:extLst>
   </p:cSld>
@@ -1648,12 +1735,12 @@
           <a:bodyPr anchor="b"/>
           <a:lstStyle>
             <a:lvl1pPr>
-              <a:defRPr sz="3200"/>
+              <a:defRPr sz="3200" b="1"/>
             </a:lvl1pPr>
           </a:lstStyle>
           <a:p>
             <a:r>
-              <a:rPr lang="ko-KR" altLang="en-US"/>
+              <a:rPr lang="ko-KR" altLang="en-US" dirty="0"/>
               <a:t>마스터 제목 스타일 편집</a:t>
             </a:r>
           </a:p>
@@ -1820,7 +1907,7 @@
           <a:p>
             <a:fld id="{C4A39A32-5728-48B8-9F9C-437D214CCAF1}" type="datetime6">
               <a:rPr lang="ko-KR" altLang="en-US" smtClean="0"/>
-              <a:t>2023년 10월</a:t>
+              <a:t>2024년 8월</a:t>
             </a:fld>
             <a:endParaRPr lang="ko-KR" altLang="en-US"/>
           </a:p>
@@ -1883,7 +1970,7 @@
     </p:spTree>
     <p:extLst>
       <p:ext uri="{BB962C8B-B14F-4D97-AF65-F5344CB8AC3E}">
-        <p14:creationId xmlns:p14="http://schemas.microsoft.com/office/powerpoint/2010/main" val="3479760054"/>
+        <p14:creationId xmlns:p14="http://schemas.microsoft.com/office/powerpoint/2010/main" val="1115106719"/>
       </p:ext>
     </p:extLst>
   </p:cSld>
@@ -1929,10 +2016,14 @@
         <p:spPr/>
         <p:txBody>
           <a:bodyPr/>
-          <a:lstStyle/>
-          <a:p>
-            <a:r>
-              <a:rPr lang="ko-KR" altLang="en-US"/>
+          <a:lstStyle>
+            <a:lvl1pPr>
+              <a:defRPr b="1"/>
+            </a:lvl1pPr>
+          </a:lstStyle>
+          <a:p>
+            <a:r>
+              <a:rPr lang="ko-KR" altLang="en-US" dirty="0"/>
               <a:t>마스터 제목 스타일 편집</a:t>
             </a:r>
           </a:p>
@@ -2018,7 +2109,7 @@
           <a:p>
             <a:fld id="{3BECC8BA-EBCB-4BF9-8E87-970CE0138376}" type="datetime6">
               <a:rPr lang="ko-KR" altLang="en-US" smtClean="0"/>
-              <a:t>2023년 10월</a:t>
+              <a:t>2024년 8월</a:t>
             </a:fld>
             <a:endParaRPr lang="ko-KR" altLang="en-US"/>
           </a:p>
@@ -2081,7 +2172,7 @@
     </p:spTree>
     <p:extLst>
       <p:ext uri="{BB962C8B-B14F-4D97-AF65-F5344CB8AC3E}">
-        <p14:creationId xmlns:p14="http://schemas.microsoft.com/office/powerpoint/2010/main" val="3934445630"/>
+        <p14:creationId xmlns:p14="http://schemas.microsoft.com/office/powerpoint/2010/main" val="2668172075"/>
       </p:ext>
     </p:extLst>
   </p:cSld>
@@ -2226,7 +2317,7 @@
           <a:p>
             <a:fld id="{7869FA6E-4699-4AC6-B2CB-4E60A58ED7A8}" type="datetime6">
               <a:rPr lang="ko-KR" altLang="en-US" smtClean="0"/>
-              <a:t>2023년 10월</a:t>
+              <a:t>2024년 8월</a:t>
             </a:fld>
             <a:endParaRPr lang="ko-KR" altLang="en-US"/>
           </a:p>
@@ -2289,7 +2380,7 @@
     </p:spTree>
     <p:extLst>
       <p:ext uri="{BB962C8B-B14F-4D97-AF65-F5344CB8AC3E}">
-        <p14:creationId xmlns:p14="http://schemas.microsoft.com/office/powerpoint/2010/main" val="1177218692"/>
+        <p14:creationId xmlns:p14="http://schemas.microsoft.com/office/powerpoint/2010/main" val="2402234184"/>
       </p:ext>
     </p:extLst>
   </p:cSld>
@@ -2339,7 +2430,7 @@
           <a:p>
             <a:fld id="{0E19CB95-6D28-40F1-9DA3-1BAC5D4B5B4F}" type="datetime6">
               <a:rPr lang="ko-KR" altLang="en-US" smtClean="0"/>
-              <a:t>2023년 10월</a:t>
+              <a:t>2024년 8월</a:t>
             </a:fld>
             <a:endParaRPr lang="ko-KR" altLang="en-US"/>
           </a:p>
@@ -2476,7 +2567,7 @@
           </a:bodyPr>
           <a:lstStyle>
             <a:lvl1pPr algn="ctr">
-              <a:defRPr sz="8000" b="0">
+              <a:defRPr sz="8000" b="1">
                 <a:solidFill>
                   <a:srgbClr val="6EC173"/>
                 </a:solidFill>
@@ -2494,7 +2585,7 @@
     </p:spTree>
     <p:extLst>
       <p:ext uri="{BB962C8B-B14F-4D97-AF65-F5344CB8AC3E}">
-        <p14:creationId xmlns:p14="http://schemas.microsoft.com/office/powerpoint/2010/main" val="2971631772"/>
+        <p14:creationId xmlns:p14="http://schemas.microsoft.com/office/powerpoint/2010/main" val="4099127136"/>
       </p:ext>
     </p:extLst>
   </p:cSld>
@@ -2601,7 +2692,7 @@
           <a:p>
             <a:fld id="{3C9CE3CE-253F-4F9D-BA15-C226C8D8501E}" type="datetime6">
               <a:rPr lang="ko-KR" altLang="en-US" smtClean="0"/>
-              <a:t>2023년 10월</a:t>
+              <a:t>2024년 8월</a:t>
             </a:fld>
             <a:endParaRPr lang="ko-KR" altLang="en-US"/>
           </a:p>
@@ -2690,7 +2781,11 @@
           <a:bodyPr vert="horz" lIns="91440" tIns="45720" rIns="91440" bIns="45720" rtlCol="0" anchor="ctr">
             <a:normAutofit/>
           </a:bodyPr>
-          <a:lstStyle/>
+          <a:lstStyle>
+            <a:lvl1pPr>
+              <a:defRPr b="1"/>
+            </a:lvl1pPr>
+          </a:lstStyle>
           <a:p>
             <a:r>
               <a:rPr lang="ko-KR" altLang="en-US" dirty="0"/>
@@ -2702,7 +2797,7 @@
     </p:spTree>
     <p:extLst>
       <p:ext uri="{BB962C8B-B14F-4D97-AF65-F5344CB8AC3E}">
-        <p14:creationId xmlns:p14="http://schemas.microsoft.com/office/powerpoint/2010/main" val="2980172866"/>
+        <p14:creationId xmlns:p14="http://schemas.microsoft.com/office/powerpoint/2010/main" val="252165120"/>
       </p:ext>
     </p:extLst>
   </p:cSld>
@@ -2914,7 +3009,7 @@
           <a:p>
             <a:fld id="{BE5A7087-D460-46DD-B430-F8D9B9677D08}" type="datetime6">
               <a:rPr lang="ko-KR" altLang="en-US" smtClean="0"/>
-              <a:t>2023년 10월</a:t>
+              <a:t>2024년 8월</a:t>
             </a:fld>
             <a:endParaRPr lang="ko-KR" altLang="en-US"/>
           </a:p>
@@ -2977,7 +3072,7 @@
     </p:spTree>
     <p:extLst>
       <p:ext uri="{BB962C8B-B14F-4D97-AF65-F5344CB8AC3E}">
-        <p14:creationId xmlns:p14="http://schemas.microsoft.com/office/powerpoint/2010/main" val="4046216683"/>
+        <p14:creationId xmlns:p14="http://schemas.microsoft.com/office/powerpoint/2010/main" val="1493691355"/>
       </p:ext>
     </p:extLst>
   </p:cSld>
@@ -3023,10 +3118,14 @@
         <p:spPr/>
         <p:txBody>
           <a:bodyPr/>
-          <a:lstStyle/>
-          <a:p>
-            <a:r>
-              <a:rPr lang="ko-KR" altLang="en-US"/>
+          <a:lstStyle>
+            <a:lvl1pPr>
+              <a:defRPr b="1"/>
+            </a:lvl1pPr>
+          </a:lstStyle>
+          <a:p>
+            <a:r>
+              <a:rPr lang="ko-KR" altLang="en-US" dirty="0"/>
               <a:t>마스터 제목 스타일 편집</a:t>
             </a:r>
           </a:p>
@@ -3179,7 +3278,7 @@
           <a:p>
             <a:fld id="{0581BA25-D675-4234-A003-8449BDEEF18E}" type="datetime6">
               <a:rPr lang="ko-KR" altLang="en-US" smtClean="0"/>
-              <a:t>2023년 10월</a:t>
+              <a:t>2024년 8월</a:t>
             </a:fld>
             <a:endParaRPr lang="ko-KR" altLang="en-US"/>
           </a:p>
@@ -3242,7 +3341,7 @@
     </p:spTree>
     <p:extLst>
       <p:ext uri="{BB962C8B-B14F-4D97-AF65-F5344CB8AC3E}">
-        <p14:creationId xmlns:p14="http://schemas.microsoft.com/office/powerpoint/2010/main" val="3411120117"/>
+        <p14:creationId xmlns:p14="http://schemas.microsoft.com/office/powerpoint/2010/main" val="2332953868"/>
       </p:ext>
     </p:extLst>
   </p:cSld>
@@ -3293,10 +3392,14 @@
         </p:spPr>
         <p:txBody>
           <a:bodyPr/>
-          <a:lstStyle/>
-          <a:p>
-            <a:r>
-              <a:rPr lang="ko-KR" altLang="en-US"/>
+          <a:lstStyle>
+            <a:lvl1pPr>
+              <a:defRPr b="1"/>
+            </a:lvl1pPr>
+          </a:lstStyle>
+          <a:p>
+            <a:r>
+              <a:rPr lang="ko-KR" altLang="en-US" dirty="0"/>
               <a:t>마스터 제목 스타일 편집</a:t>
             </a:r>
           </a:p>
@@ -3591,7 +3694,7 @@
           <a:p>
             <a:fld id="{26155C29-A87F-46F0-A24C-6C9F0A4BF6AA}" type="datetime6">
               <a:rPr lang="ko-KR" altLang="en-US" smtClean="0"/>
-              <a:t>2023년 10월</a:t>
+              <a:t>2024년 8월</a:t>
             </a:fld>
             <a:endParaRPr lang="ko-KR" altLang="en-US"/>
           </a:p>
@@ -3654,7 +3757,7 @@
     </p:spTree>
     <p:extLst>
       <p:ext uri="{BB962C8B-B14F-4D97-AF65-F5344CB8AC3E}">
-        <p14:creationId xmlns:p14="http://schemas.microsoft.com/office/powerpoint/2010/main" val="1321266429"/>
+        <p14:creationId xmlns:p14="http://schemas.microsoft.com/office/powerpoint/2010/main" val="2040342772"/>
       </p:ext>
     </p:extLst>
   </p:cSld>
@@ -3700,10 +3803,14 @@
         <p:spPr/>
         <p:txBody>
           <a:bodyPr/>
-          <a:lstStyle/>
-          <a:p>
-            <a:r>
-              <a:rPr lang="ko-KR" altLang="en-US"/>
+          <a:lstStyle>
+            <a:lvl1pPr>
+              <a:defRPr b="1"/>
+            </a:lvl1pPr>
+          </a:lstStyle>
+          <a:p>
+            <a:r>
+              <a:rPr lang="ko-KR" altLang="en-US" dirty="0"/>
               <a:t>마스터 제목 스타일 편집</a:t>
             </a:r>
           </a:p>
@@ -3732,7 +3839,7 @@
           <a:p>
             <a:fld id="{DD2EDD62-8757-43DB-BAE0-460422B548EA}" type="datetime6">
               <a:rPr lang="ko-KR" altLang="en-US" smtClean="0"/>
-              <a:t>2023년 10월</a:t>
+              <a:t>2024년 8월</a:t>
             </a:fld>
             <a:endParaRPr lang="ko-KR" altLang="en-US"/>
           </a:p>
@@ -3795,7 +3902,7 @@
     </p:spTree>
     <p:extLst>
       <p:ext uri="{BB962C8B-B14F-4D97-AF65-F5344CB8AC3E}">
-        <p14:creationId xmlns:p14="http://schemas.microsoft.com/office/powerpoint/2010/main" val="872652224"/>
+        <p14:creationId xmlns:p14="http://schemas.microsoft.com/office/powerpoint/2010/main" val="674941843"/>
       </p:ext>
     </p:extLst>
   </p:cSld>
@@ -3845,7 +3952,7 @@
           <a:p>
             <a:fld id="{DC6A871B-4800-495F-AC75-93D44C7DEBA5}" type="datetime6">
               <a:rPr lang="ko-KR" altLang="en-US" smtClean="0"/>
-              <a:t>2023년 10월</a:t>
+              <a:t>2024년 8월</a:t>
             </a:fld>
             <a:endParaRPr lang="ko-KR" altLang="en-US"/>
           </a:p>
@@ -3908,7 +4015,7 @@
     </p:spTree>
     <p:extLst>
       <p:ext uri="{BB962C8B-B14F-4D97-AF65-F5344CB8AC3E}">
-        <p14:creationId xmlns:p14="http://schemas.microsoft.com/office/powerpoint/2010/main" val="2439034898"/>
+        <p14:creationId xmlns:p14="http://schemas.microsoft.com/office/powerpoint/2010/main" val="3923660425"/>
       </p:ext>
     </p:extLst>
   </p:cSld>
@@ -3961,12 +4068,12 @@
           <a:bodyPr anchor="b"/>
           <a:lstStyle>
             <a:lvl1pPr>
-              <a:defRPr sz="3200"/>
+              <a:defRPr sz="3200" b="1"/>
             </a:lvl1pPr>
           </a:lstStyle>
           <a:p>
             <a:r>
-              <a:rPr lang="ko-KR" altLang="en-US"/>
+              <a:rPr lang="ko-KR" altLang="en-US" dirty="0"/>
               <a:t>마스터 제목 스타일 편집</a:t>
             </a:r>
           </a:p>
@@ -4156,7 +4263,7 @@
           <a:p>
             <a:fld id="{59605888-30A6-49BB-95E2-DEAE4E5B09E9}" type="datetime6">
               <a:rPr lang="ko-KR" altLang="en-US" smtClean="0"/>
-              <a:t>2023년 10월</a:t>
+              <a:t>2024년 8월</a:t>
             </a:fld>
             <a:endParaRPr lang="ko-KR" altLang="en-US"/>
           </a:p>
@@ -4219,7 +4326,7 @@
     </p:spTree>
     <p:extLst>
       <p:ext uri="{BB962C8B-B14F-4D97-AF65-F5344CB8AC3E}">
-        <p14:creationId xmlns:p14="http://schemas.microsoft.com/office/powerpoint/2010/main" val="1170746380"/>
+        <p14:creationId xmlns:p14="http://schemas.microsoft.com/office/powerpoint/2010/main" val="1172622370"/>
       </p:ext>
     </p:extLst>
   </p:cSld>
@@ -4322,35 +4429,35 @@
           <a:p>
             <a:pPr lvl="0"/>
             <a:r>
-              <a:rPr lang="ko-KR" altLang="en-US"/>
+              <a:rPr lang="ko-KR" altLang="en-US" dirty="0"/>
               <a:t>마스터 텍스트 스타일을 편집하려면 클릭</a:t>
             </a:r>
           </a:p>
           <a:p>
             <a:pPr lvl="1"/>
             <a:r>
-              <a:rPr lang="ko-KR" altLang="en-US"/>
+              <a:rPr lang="ko-KR" altLang="en-US" dirty="0"/>
               <a:t>두 번째 수준</a:t>
             </a:r>
           </a:p>
           <a:p>
             <a:pPr lvl="2"/>
             <a:r>
-              <a:rPr lang="ko-KR" altLang="en-US"/>
+              <a:rPr lang="ko-KR" altLang="en-US" dirty="0"/>
               <a:t>세 번째 수준</a:t>
             </a:r>
           </a:p>
           <a:p>
             <a:pPr lvl="3"/>
             <a:r>
-              <a:rPr lang="ko-KR" altLang="en-US"/>
+              <a:rPr lang="ko-KR" altLang="en-US" dirty="0"/>
               <a:t>네 번째 수준</a:t>
             </a:r>
           </a:p>
           <a:p>
             <a:pPr lvl="4"/>
             <a:r>
-              <a:rPr lang="ko-KR" altLang="en-US"/>
+              <a:rPr lang="ko-KR" altLang="en-US" dirty="0"/>
               <a:t>다섯 번째 수준</a:t>
             </a:r>
           </a:p>
@@ -4397,7 +4504,7 @@
           <a:p>
             <a:fld id="{8691C14A-5735-4A8B-B68B-DEC1DC2A3813}" type="datetime6">
               <a:rPr lang="ko-KR" altLang="en-US" smtClean="0"/>
-              <a:t>2023년 10월</a:t>
+              <a:t>2024년 8월</a:t>
             </a:fld>
             <a:endParaRPr lang="ko-KR" altLang="en-US"/>
           </a:p>
@@ -4549,10 +4656,10 @@
       </p:sp>
       <p:pic>
         <p:nvPicPr>
-          <p:cNvPr id="9" name="그림 8" descr="텍스트, 클립아트이(가) 표시된 사진&#10;&#10;자동 생성된 설명">
+          <p:cNvPr id="14" name="그림 13" descr="그래픽, 그래픽 디자인, 폰트, 원이(가) 표시된 사진&#10;&#10;자동 생성된 설명">
             <a:extLst>
               <a:ext uri="{FF2B5EF4-FFF2-40B4-BE49-F238E27FC236}">
-                <a16:creationId xmlns:a16="http://schemas.microsoft.com/office/drawing/2014/main" id="{CFFA81A6-6D9A-9C22-6A01-103FCC7108B8}"/>
+                <a16:creationId xmlns:a16="http://schemas.microsoft.com/office/drawing/2014/main" id="{0EB71D7B-83F1-1414-954A-8C79751B7793}"/>
               </a:ext>
             </a:extLst>
           </p:cNvPr>
@@ -4562,8 +4669,7 @@
           <p:nvPr userDrawn="1"/>
         </p:nvPicPr>
         <p:blipFill>
-          <a:blip r:embed="rId14" cstate="hqprint">
-            <a:alphaModFix/>
+          <a:blip r:embed="rId14">
             <a:extLst>
               <a:ext uri="{28A0092B-C50C-407E-A947-70E740481C1C}">
                 <a14:useLocalDpi xmlns:a14="http://schemas.microsoft.com/office/drawing/2010/main" val="0"/>
@@ -4576,136 +4682,35 @@
         </p:blipFill>
         <p:spPr>
           <a:xfrm>
-            <a:off x="11044576" y="140110"/>
-            <a:ext cx="1026976" cy="205105"/>
+            <a:off x="10835681" y="96056"/>
+            <a:ext cx="1260000" cy="270857"/>
           </a:xfrm>
           <a:prstGeom prst="rect">
             <a:avLst/>
           </a:prstGeom>
         </p:spPr>
       </p:pic>
-      <p:sp>
-        <p:nvSpPr>
-          <p:cNvPr id="10" name="TextBox 9">
-            <a:extLst>
-              <a:ext uri="{FF2B5EF4-FFF2-40B4-BE49-F238E27FC236}">
-                <a16:creationId xmlns:a16="http://schemas.microsoft.com/office/drawing/2014/main" id="{2E8CEA0B-0194-B9A0-705F-CAB04B3523DA}"/>
-              </a:ext>
-            </a:extLst>
-          </p:cNvPr>
-          <p:cNvSpPr txBox="1"/>
-          <p:nvPr userDrawn="1"/>
-        </p:nvSpPr>
-        <p:spPr>
-          <a:xfrm>
-            <a:off x="10814758" y="104713"/>
-            <a:ext cx="227015" cy="307777"/>
-          </a:xfrm>
-          <a:prstGeom prst="rect">
-            <a:avLst/>
-          </a:prstGeom>
-          <a:noFill/>
-        </p:spPr>
-        <p:txBody>
-          <a:bodyPr wrap="square" rtlCol="0">
-            <a:spAutoFit/>
-          </a:bodyPr>
-          <a:lstStyle/>
-          <a:p>
-            <a:pPr algn="ctr"/>
-            <a:r>
-              <a:rPr lang="en-US" altLang="ko-KR" sz="1400" b="1" dirty="0">
-                <a:solidFill>
-                  <a:schemeClr val="tx1"/>
-                </a:solidFill>
-              </a:rPr>
-              <a:t>X</a:t>
-            </a:r>
-            <a:endParaRPr lang="ko-KR" altLang="en-US" sz="2000" b="1" dirty="0">
-              <a:solidFill>
-                <a:schemeClr val="tx1"/>
-              </a:solidFill>
-            </a:endParaRPr>
-          </a:p>
-        </p:txBody>
-      </p:sp>
-      <p:pic>
-        <p:nvPicPr>
-          <p:cNvPr id="11" name="Picture 4" descr="청년취업사관학교, 새싹(SeSAC) - YouTube">
-            <a:extLst>
-              <a:ext uri="{FF2B5EF4-FFF2-40B4-BE49-F238E27FC236}">
-                <a16:creationId xmlns:a16="http://schemas.microsoft.com/office/drawing/2014/main" id="{AD5D531A-42B5-6D12-7A47-FFEB75D29CB0}"/>
-              </a:ext>
-            </a:extLst>
-          </p:cNvPr>
-          <p:cNvPicPr>
-            <a:picLocks noChangeAspect="1" noChangeArrowheads="1"/>
-          </p:cNvPicPr>
-          <p:nvPr userDrawn="1"/>
-        </p:nvPicPr>
-        <p:blipFill>
-          <a:blip r:embed="rId15" cstate="hqprint">
-            <a:extLst>
-              <a:ext uri="{BEBA8EAE-BF5A-486C-A8C5-ECC9F3942E4B}">
-                <a14:imgProps xmlns:a14="http://schemas.microsoft.com/office/drawing/2010/main">
-                  <a14:imgLayer r:embed="rId16">
-                    <a14:imgEffect>
-                      <a14:backgroundRemoval t="10000" b="90000" l="10000" r="90000"/>
-                    </a14:imgEffect>
-                  </a14:imgLayer>
-                </a14:imgProps>
-              </a:ext>
-              <a:ext uri="{28A0092B-C50C-407E-A947-70E740481C1C}">
-                <a14:useLocalDpi xmlns:a14="http://schemas.microsoft.com/office/drawing/2010/main" val="0"/>
-              </a:ext>
-            </a:extLst>
-          </a:blip>
-          <a:srcRect/>
-          <a:stretch>
-            <a:fillRect/>
-          </a:stretch>
-        </p:blipFill>
-        <p:spPr bwMode="auto">
-          <a:xfrm>
-            <a:off x="10492653" y="54125"/>
-            <a:ext cx="371243" cy="371243"/>
-          </a:xfrm>
-          <a:prstGeom prst="rect">
-            <a:avLst/>
-          </a:prstGeom>
-          <a:noFill/>
-          <a:extLst>
-            <a:ext uri="{909E8E84-426E-40DD-AFC4-6F175D3DCCD1}">
-              <a14:hiddenFill xmlns:a14="http://schemas.microsoft.com/office/drawing/2010/main">
-                <a:solidFill>
-                  <a:srgbClr val="FFFFFF"/>
-                </a:solidFill>
-              </a14:hiddenFill>
-            </a:ext>
-          </a:extLst>
-        </p:spPr>
-      </p:pic>
     </p:spTree>
     <p:extLst>
       <p:ext uri="{BB962C8B-B14F-4D97-AF65-F5344CB8AC3E}">
-        <p14:creationId xmlns:p14="http://schemas.microsoft.com/office/powerpoint/2010/main" val="21425045"/>
+        <p14:creationId xmlns:p14="http://schemas.microsoft.com/office/powerpoint/2010/main" val="3936322041"/>
       </p:ext>
     </p:extLst>
   </p:cSld>
   <p:clrMap bg1="lt1" tx1="dk1" bg2="lt2" tx2="dk2" accent1="accent1" accent2="accent2" accent3="accent3" accent4="accent4" accent5="accent5" accent6="accent6" hlink="hlink" folHlink="folHlink"/>
   <p:sldLayoutIdLst>
-    <p:sldLayoutId id="2147483661" r:id="rId1"/>
-    <p:sldLayoutId id="2147483662" r:id="rId2"/>
-    <p:sldLayoutId id="2147483663" r:id="rId3"/>
-    <p:sldLayoutId id="2147483664" r:id="rId4"/>
-    <p:sldLayoutId id="2147483665" r:id="rId5"/>
-    <p:sldLayoutId id="2147483666" r:id="rId6"/>
-    <p:sldLayoutId id="2147483667" r:id="rId7"/>
-    <p:sldLayoutId id="2147483668" r:id="rId8"/>
-    <p:sldLayoutId id="2147483669" r:id="rId9"/>
-    <p:sldLayoutId id="2147483670" r:id="rId10"/>
-    <p:sldLayoutId id="2147483671" r:id="rId11"/>
-    <p:sldLayoutId id="2147483672" r:id="rId12"/>
+    <p:sldLayoutId id="2147483674" r:id="rId1"/>
+    <p:sldLayoutId id="2147483675" r:id="rId2"/>
+    <p:sldLayoutId id="2147483676" r:id="rId3"/>
+    <p:sldLayoutId id="2147483677" r:id="rId4"/>
+    <p:sldLayoutId id="2147483678" r:id="rId5"/>
+    <p:sldLayoutId id="2147483679" r:id="rId6"/>
+    <p:sldLayoutId id="2147483680" r:id="rId7"/>
+    <p:sldLayoutId id="2147483681" r:id="rId8"/>
+    <p:sldLayoutId id="2147483682" r:id="rId9"/>
+    <p:sldLayoutId id="2147483683" r:id="rId10"/>
+    <p:sldLayoutId id="2147483684" r:id="rId11"/>
+    <p:sldLayoutId id="2147483685" r:id="rId12"/>
   </p:sldLayoutIdLst>
   <p:hf hdr="0" ftr="0"/>
   <p:txStyles>
@@ -4718,7 +4723,7 @@
           <a:spcPct val="0"/>
         </a:spcBef>
         <a:buNone/>
-        <a:defRPr sz="4400" kern="1200">
+        <a:defRPr sz="4400" b="1" kern="1200">
           <a:solidFill>
             <a:schemeClr val="tx1"/>
           </a:solidFill>
@@ -5084,7 +5089,7 @@
           <a:p>
             <a:fld id="{4DA02FB7-A3D0-4BF4-B23F-90A4C3B73A56}" type="datetime6">
               <a:rPr lang="ko-KR" altLang="en-US" smtClean="0"/>
-              <a:t>2023년 10월</a:t>
+              <a:t>2024년 8월</a:t>
             </a:fld>
             <a:endParaRPr lang="ko-KR" altLang="en-US" dirty="0"/>
           </a:p>
@@ -5123,6 +5128,584 @@
     <p:extLst>
       <p:ext uri="{BB962C8B-B14F-4D97-AF65-F5344CB8AC3E}">
         <p14:creationId xmlns:p14="http://schemas.microsoft.com/office/powerpoint/2010/main" val="3330293221"/>
+      </p:ext>
+    </p:extLst>
+  </p:cSld>
+  <p:clrMapOvr>
+    <a:masterClrMapping/>
+  </p:clrMapOvr>
+</p:sld>
+</file>
+
+<file path=ppt/slides/slide10.xml><?xml version="1.0" encoding="utf-8"?>
+<p:sld xmlns:a="http://schemas.openxmlformats.org/drawingml/2006/main" xmlns:r="http://schemas.openxmlformats.org/officeDocument/2006/relationships" xmlns:p="http://schemas.openxmlformats.org/presentationml/2006/main">
+  <p:cSld>
+    <p:spTree>
+      <p:nvGrpSpPr>
+        <p:cNvPr id="1" name=""/>
+        <p:cNvGrpSpPr/>
+        <p:nvPr/>
+      </p:nvGrpSpPr>
+      <p:grpSpPr>
+        <a:xfrm>
+          <a:off x="0" y="0"/>
+          <a:ext cx="0" cy="0"/>
+          <a:chOff x="0" y="0"/>
+          <a:chExt cx="0" cy="0"/>
+        </a:xfrm>
+      </p:grpSpPr>
+      <p:sp>
+        <p:nvSpPr>
+          <p:cNvPr id="13" name="내용 개체 틀 2">
+            <a:extLst>
+              <a:ext uri="{FF2B5EF4-FFF2-40B4-BE49-F238E27FC236}">
+                <a16:creationId xmlns:a16="http://schemas.microsoft.com/office/drawing/2014/main" id="{847FD532-7F61-A001-537F-B970BD821AF3}"/>
+              </a:ext>
+            </a:extLst>
+          </p:cNvPr>
+          <p:cNvSpPr>
+            <a:spLocks noGrp="1"/>
+          </p:cNvSpPr>
+          <p:nvPr>
+            <p:ph idx="1"/>
+          </p:nvPr>
+        </p:nvSpPr>
+        <p:spPr>
+          <a:xfrm>
+            <a:off x="510988" y="1328391"/>
+            <a:ext cx="11260802" cy="5328442"/>
+          </a:xfrm>
+        </p:spPr>
+        <p:txBody>
+          <a:bodyPr>
+            <a:normAutofit/>
+          </a:bodyPr>
+          <a:lstStyle/>
+          <a:p>
+            <a:endParaRPr lang="en-US" altLang="ko-KR" dirty="0"/>
+          </a:p>
+          <a:p>
+            <a:pPr marL="0" indent="0">
+              <a:buNone/>
+            </a:pPr>
+            <a:endParaRPr lang="en-US" altLang="ko-KR" dirty="0"/>
+          </a:p>
+          <a:p>
+            <a:pPr marL="0" indent="0">
+              <a:buNone/>
+            </a:pPr>
+            <a:endParaRPr lang="en-US" altLang="ko-KR" dirty="0"/>
+          </a:p>
+        </p:txBody>
+      </p:sp>
+      <p:sp>
+        <p:nvSpPr>
+          <p:cNvPr id="4" name="날짜 개체 틀 3">
+            <a:extLst>
+              <a:ext uri="{FF2B5EF4-FFF2-40B4-BE49-F238E27FC236}">
+                <a16:creationId xmlns:a16="http://schemas.microsoft.com/office/drawing/2014/main" id="{A695DDE5-0A39-A366-4CFE-A283911999CD}"/>
+              </a:ext>
+            </a:extLst>
+          </p:cNvPr>
+          <p:cNvSpPr>
+            <a:spLocks noGrp="1"/>
+          </p:cNvSpPr>
+          <p:nvPr>
+            <p:ph type="dt" sz="half" idx="10"/>
+          </p:nvPr>
+        </p:nvSpPr>
+        <p:spPr/>
+        <p:txBody>
+          <a:bodyPr/>
+          <a:lstStyle/>
+          <a:p>
+            <a:fld id="{0F78D9C4-20C1-4B15-A116-16DC77AD9A1E}" type="datetime1">
+              <a:rPr lang="ko-KR" altLang="en-US" smtClean="0"/>
+              <a:t>2024-08-21</a:t>
+            </a:fld>
+            <a:endParaRPr lang="ko-KR" altLang="en-US" dirty="0"/>
+          </a:p>
+        </p:txBody>
+      </p:sp>
+      <p:sp>
+        <p:nvSpPr>
+          <p:cNvPr id="5" name="슬라이드 번호 개체 틀 4">
+            <a:extLst>
+              <a:ext uri="{FF2B5EF4-FFF2-40B4-BE49-F238E27FC236}">
+                <a16:creationId xmlns:a16="http://schemas.microsoft.com/office/drawing/2014/main" id="{5E040F43-60A7-C50D-1F5B-F984054F2D7C}"/>
+              </a:ext>
+            </a:extLst>
+          </p:cNvPr>
+          <p:cNvSpPr>
+            <a:spLocks noGrp="1"/>
+          </p:cNvSpPr>
+          <p:nvPr>
+            <p:ph type="sldNum" sz="quarter" idx="12"/>
+          </p:nvPr>
+        </p:nvSpPr>
+        <p:spPr/>
+        <p:txBody>
+          <a:bodyPr/>
+          <a:lstStyle/>
+          <a:p>
+            <a:fld id="{083A2CE0-18CD-4102-B738-4ACFF9E68BA4}" type="slidenum">
+              <a:rPr lang="ko-KR" altLang="en-US" smtClean="0"/>
+              <a:t>10</a:t>
+            </a:fld>
+            <a:endParaRPr lang="ko-KR" altLang="en-US"/>
+          </a:p>
+        </p:txBody>
+      </p:sp>
+      <p:sp>
+        <p:nvSpPr>
+          <p:cNvPr id="2" name="제목 1">
+            <a:extLst>
+              <a:ext uri="{FF2B5EF4-FFF2-40B4-BE49-F238E27FC236}">
+                <a16:creationId xmlns:a16="http://schemas.microsoft.com/office/drawing/2014/main" id="{5FAC57F5-99D7-9C46-B6C1-D16224151FE9}"/>
+              </a:ext>
+            </a:extLst>
+          </p:cNvPr>
+          <p:cNvSpPr>
+            <a:spLocks noGrp="1"/>
+          </p:cNvSpPr>
+          <p:nvPr>
+            <p:ph type="title"/>
+          </p:nvPr>
+        </p:nvSpPr>
+        <p:spPr/>
+        <p:txBody>
+          <a:bodyPr/>
+          <a:lstStyle/>
+          <a:p>
+            <a:r>
+              <a:rPr lang="ko-KR" altLang="en-US" dirty="0">
+                <a:solidFill>
+                  <a:srgbClr val="6EC173"/>
+                </a:solidFill>
+              </a:rPr>
+              <a:t>실습</a:t>
+            </a:r>
+            <a:r>
+              <a:rPr lang="en-US" altLang="ko-KR" dirty="0">
+                <a:solidFill>
+                  <a:srgbClr val="6EC173"/>
+                </a:solidFill>
+              </a:rPr>
+              <a:t>.  </a:t>
+            </a:r>
+            <a:r>
+              <a:rPr lang="en-US" altLang="ko-KR" dirty="0"/>
+              <a:t> React with TS </a:t>
+            </a:r>
+            <a:r>
+              <a:rPr lang="ko-KR" altLang="en-US" dirty="0"/>
+              <a:t>실습</a:t>
+            </a:r>
+          </a:p>
+        </p:txBody>
+      </p:sp>
+      <p:sp>
+        <p:nvSpPr>
+          <p:cNvPr id="6" name="내용 개체 틀 1">
+            <a:extLst>
+              <a:ext uri="{FF2B5EF4-FFF2-40B4-BE49-F238E27FC236}">
+                <a16:creationId xmlns:a16="http://schemas.microsoft.com/office/drawing/2014/main" id="{70C2BA37-BE91-39C4-AC08-0E8A1052E2F7}"/>
+              </a:ext>
+            </a:extLst>
+          </p:cNvPr>
+          <p:cNvSpPr txBox="1">
+            <a:spLocks/>
+          </p:cNvSpPr>
+          <p:nvPr/>
+        </p:nvSpPr>
+        <p:spPr>
+          <a:xfrm>
+            <a:off x="838200" y="1825625"/>
+            <a:ext cx="10515600" cy="4351338"/>
+          </a:xfrm>
+          <a:prstGeom prst="rect">
+            <a:avLst/>
+          </a:prstGeom>
+        </p:spPr>
+        <p:txBody>
+          <a:bodyPr vert="horz" lIns="91440" tIns="45720" rIns="91440" bIns="45720" rtlCol="0">
+            <a:normAutofit/>
+          </a:bodyPr>
+          <a:lstStyle>
+            <a:lvl1pPr marL="228600" indent="-228600" algn="l" defTabSz="914400" rtl="0" eaLnBrk="1" latinLnBrk="1" hangingPunct="1">
+              <a:lnSpc>
+                <a:spcPct val="90000"/>
+              </a:lnSpc>
+              <a:spcBef>
+                <a:spcPts val="1000"/>
+              </a:spcBef>
+              <a:buFont typeface="Arial" panose="020B0604020202020204" pitchFamily="34" charset="0"/>
+              <a:buChar char="•"/>
+              <a:defRPr sz="2800" kern="1200">
+                <a:solidFill>
+                  <a:schemeClr val="tx1"/>
+                </a:solidFill>
+                <a:latin typeface="+mn-lt"/>
+                <a:ea typeface="+mn-ea"/>
+                <a:cs typeface="+mn-cs"/>
+              </a:defRPr>
+            </a:lvl1pPr>
+            <a:lvl2pPr marL="685800" indent="-228600" algn="l" defTabSz="914400" rtl="0" eaLnBrk="1" latinLnBrk="1" hangingPunct="1">
+              <a:lnSpc>
+                <a:spcPct val="90000"/>
+              </a:lnSpc>
+              <a:spcBef>
+                <a:spcPts val="500"/>
+              </a:spcBef>
+              <a:buFont typeface="Arial" panose="020B0604020202020204" pitchFamily="34" charset="0"/>
+              <a:buChar char="•"/>
+              <a:defRPr sz="2400" kern="1200">
+                <a:solidFill>
+                  <a:schemeClr val="tx1"/>
+                </a:solidFill>
+                <a:latin typeface="+mn-lt"/>
+                <a:ea typeface="+mn-ea"/>
+                <a:cs typeface="+mn-cs"/>
+              </a:defRPr>
+            </a:lvl2pPr>
+            <a:lvl3pPr marL="1143000" indent="-228600" algn="l" defTabSz="914400" rtl="0" eaLnBrk="1" latinLnBrk="1" hangingPunct="1">
+              <a:lnSpc>
+                <a:spcPct val="90000"/>
+              </a:lnSpc>
+              <a:spcBef>
+                <a:spcPts val="500"/>
+              </a:spcBef>
+              <a:buFont typeface="Arial" panose="020B0604020202020204" pitchFamily="34" charset="0"/>
+              <a:buChar char="•"/>
+              <a:defRPr sz="2000" kern="1200">
+                <a:solidFill>
+                  <a:schemeClr val="tx1"/>
+                </a:solidFill>
+                <a:latin typeface="+mn-lt"/>
+                <a:ea typeface="+mn-ea"/>
+                <a:cs typeface="+mn-cs"/>
+              </a:defRPr>
+            </a:lvl3pPr>
+            <a:lvl4pPr marL="1600200" indent="-228600" algn="l" defTabSz="914400" rtl="0" eaLnBrk="1" latinLnBrk="1" hangingPunct="1">
+              <a:lnSpc>
+                <a:spcPct val="90000"/>
+              </a:lnSpc>
+              <a:spcBef>
+                <a:spcPts val="500"/>
+              </a:spcBef>
+              <a:buFont typeface="Arial" panose="020B0604020202020204" pitchFamily="34" charset="0"/>
+              <a:buChar char="•"/>
+              <a:defRPr sz="1800" kern="1200">
+                <a:solidFill>
+                  <a:schemeClr val="tx1"/>
+                </a:solidFill>
+                <a:latin typeface="+mn-lt"/>
+                <a:ea typeface="+mn-ea"/>
+                <a:cs typeface="+mn-cs"/>
+              </a:defRPr>
+            </a:lvl4pPr>
+            <a:lvl5pPr marL="2057400" indent="-228600" algn="l" defTabSz="914400" rtl="0" eaLnBrk="1" latinLnBrk="1" hangingPunct="1">
+              <a:lnSpc>
+                <a:spcPct val="90000"/>
+              </a:lnSpc>
+              <a:spcBef>
+                <a:spcPts val="500"/>
+              </a:spcBef>
+              <a:buFont typeface="Arial" panose="020B0604020202020204" pitchFamily="34" charset="0"/>
+              <a:buChar char="•"/>
+              <a:defRPr sz="1800" kern="1200">
+                <a:solidFill>
+                  <a:schemeClr val="tx1"/>
+                </a:solidFill>
+                <a:latin typeface="+mn-lt"/>
+                <a:ea typeface="+mn-ea"/>
+                <a:cs typeface="+mn-cs"/>
+              </a:defRPr>
+            </a:lvl5pPr>
+            <a:lvl6pPr marL="2514600" indent="-228600" algn="l" defTabSz="914400" rtl="0" eaLnBrk="1" latinLnBrk="1" hangingPunct="1">
+              <a:lnSpc>
+                <a:spcPct val="90000"/>
+              </a:lnSpc>
+              <a:spcBef>
+                <a:spcPts val="500"/>
+              </a:spcBef>
+              <a:buFont typeface="Arial" panose="020B0604020202020204" pitchFamily="34" charset="0"/>
+              <a:buChar char="•"/>
+              <a:defRPr sz="1800" kern="1200">
+                <a:solidFill>
+                  <a:schemeClr val="tx1"/>
+                </a:solidFill>
+                <a:latin typeface="+mn-lt"/>
+                <a:ea typeface="+mn-ea"/>
+                <a:cs typeface="+mn-cs"/>
+              </a:defRPr>
+            </a:lvl6pPr>
+            <a:lvl7pPr marL="2971800" indent="-228600" algn="l" defTabSz="914400" rtl="0" eaLnBrk="1" latinLnBrk="1" hangingPunct="1">
+              <a:lnSpc>
+                <a:spcPct val="90000"/>
+              </a:lnSpc>
+              <a:spcBef>
+                <a:spcPts val="500"/>
+              </a:spcBef>
+              <a:buFont typeface="Arial" panose="020B0604020202020204" pitchFamily="34" charset="0"/>
+              <a:buChar char="•"/>
+              <a:defRPr sz="1800" kern="1200">
+                <a:solidFill>
+                  <a:schemeClr val="tx1"/>
+                </a:solidFill>
+                <a:latin typeface="+mn-lt"/>
+                <a:ea typeface="+mn-ea"/>
+                <a:cs typeface="+mn-cs"/>
+              </a:defRPr>
+            </a:lvl7pPr>
+            <a:lvl8pPr marL="3429000" indent="-228600" algn="l" defTabSz="914400" rtl="0" eaLnBrk="1" latinLnBrk="1" hangingPunct="1">
+              <a:lnSpc>
+                <a:spcPct val="90000"/>
+              </a:lnSpc>
+              <a:spcBef>
+                <a:spcPts val="500"/>
+              </a:spcBef>
+              <a:buFont typeface="Arial" panose="020B0604020202020204" pitchFamily="34" charset="0"/>
+              <a:buChar char="•"/>
+              <a:defRPr sz="1800" kern="1200">
+                <a:solidFill>
+                  <a:schemeClr val="tx1"/>
+                </a:solidFill>
+                <a:latin typeface="+mn-lt"/>
+                <a:ea typeface="+mn-ea"/>
+                <a:cs typeface="+mn-cs"/>
+              </a:defRPr>
+            </a:lvl8pPr>
+            <a:lvl9pPr marL="3886200" indent="-228600" algn="l" defTabSz="914400" rtl="0" eaLnBrk="1" latinLnBrk="1" hangingPunct="1">
+              <a:lnSpc>
+                <a:spcPct val="90000"/>
+              </a:lnSpc>
+              <a:spcBef>
+                <a:spcPts val="500"/>
+              </a:spcBef>
+              <a:buFont typeface="Arial" panose="020B0604020202020204" pitchFamily="34" charset="0"/>
+              <a:buChar char="•"/>
+              <a:defRPr sz="1800" kern="1200">
+                <a:solidFill>
+                  <a:schemeClr val="tx1"/>
+                </a:solidFill>
+                <a:latin typeface="+mn-lt"/>
+                <a:ea typeface="+mn-ea"/>
+                <a:cs typeface="+mn-cs"/>
+              </a:defRPr>
+            </a:lvl9pPr>
+          </a:lstStyle>
+          <a:p>
+            <a:pPr marL="457200" lvl="1" indent="0">
+              <a:buFont typeface="Arial" panose="020B0604020202020204" pitchFamily="34" charset="0"/>
+              <a:buNone/>
+            </a:pPr>
+            <a:endParaRPr lang="en-US" altLang="ko-KR" dirty="0">
+              <a:solidFill>
+                <a:srgbClr val="212529"/>
+              </a:solidFill>
+              <a:latin typeface="+mn-ea"/>
+            </a:endParaRPr>
+          </a:p>
+          <a:p>
+            <a:pPr marL="457200" lvl="1" indent="0">
+              <a:buFont typeface="Arial" panose="020B0604020202020204" pitchFamily="34" charset="0"/>
+              <a:buNone/>
+            </a:pPr>
+            <a:endParaRPr lang="en-US" altLang="ko-KR" dirty="0">
+              <a:solidFill>
+                <a:srgbClr val="212529"/>
+              </a:solidFill>
+              <a:latin typeface="+mn-ea"/>
+            </a:endParaRPr>
+          </a:p>
+          <a:p>
+            <a:r>
+              <a:rPr lang="en-US" altLang="ko-KR" b="1" dirty="0">
+                <a:solidFill>
+                  <a:srgbClr val="212529"/>
+                </a:solidFill>
+                <a:latin typeface="+mn-ea"/>
+              </a:rPr>
+              <a:t>[</a:t>
+            </a:r>
+            <a:r>
+              <a:rPr lang="ko-KR" altLang="en-US" b="1" dirty="0" err="1">
+                <a:solidFill>
+                  <a:srgbClr val="212529"/>
+                </a:solidFill>
+                <a:latin typeface="+mn-ea"/>
+              </a:rPr>
+              <a:t>코딩온</a:t>
+            </a:r>
+            <a:r>
+              <a:rPr lang="en-US" altLang="ko-KR" b="1" dirty="0">
+                <a:solidFill>
+                  <a:srgbClr val="212529"/>
+                </a:solidFill>
+                <a:latin typeface="+mn-ea"/>
+              </a:rPr>
+              <a:t>] React </a:t>
+            </a:r>
+            <a:r>
+              <a:rPr lang="ko-KR" altLang="en-US" b="1" dirty="0">
+                <a:solidFill>
+                  <a:srgbClr val="212529"/>
+                </a:solidFill>
+                <a:latin typeface="+mn-ea"/>
+              </a:rPr>
+              <a:t>실습 </a:t>
+            </a:r>
+            <a:r>
+              <a:rPr lang="ko-KR" altLang="en-US" dirty="0">
+                <a:solidFill>
+                  <a:srgbClr val="212529"/>
+                </a:solidFill>
+                <a:latin typeface="+mn-ea"/>
+              </a:rPr>
+              <a:t>강의 클릭</a:t>
+            </a:r>
+            <a:br>
+              <a:rPr lang="en-US" altLang="ko-KR" dirty="0">
+                <a:solidFill>
+                  <a:srgbClr val="212529"/>
+                </a:solidFill>
+                <a:latin typeface="+mn-ea"/>
+              </a:rPr>
+            </a:br>
+            <a:endParaRPr lang="en-US" altLang="ko-KR" dirty="0">
+              <a:solidFill>
+                <a:srgbClr val="212529"/>
+              </a:solidFill>
+              <a:latin typeface="+mn-ea"/>
+            </a:endParaRPr>
+          </a:p>
+          <a:p>
+            <a:pPr lvl="1"/>
+            <a:r>
+              <a:rPr lang="ko-KR" altLang="en-US" sz="2800" b="1" dirty="0">
+                <a:solidFill>
+                  <a:srgbClr val="212529"/>
+                </a:solidFill>
+                <a:latin typeface="+mn-ea"/>
+              </a:rPr>
+              <a:t>➡ </a:t>
+            </a:r>
+            <a:r>
+              <a:rPr lang="en-US" altLang="ko-KR" sz="2800" b="1" dirty="0">
+                <a:solidFill>
+                  <a:srgbClr val="212529"/>
+                </a:solidFill>
+                <a:latin typeface="+mn-ea"/>
+              </a:rPr>
+              <a:t>[React with TS </a:t>
+            </a:r>
+            <a:r>
+              <a:rPr lang="ko-KR" altLang="en-US" sz="2800" b="1" dirty="0">
+                <a:solidFill>
+                  <a:srgbClr val="212529"/>
+                </a:solidFill>
+                <a:latin typeface="+mn-ea"/>
+              </a:rPr>
+              <a:t>실습</a:t>
+            </a:r>
+            <a:r>
+              <a:rPr lang="en-US" altLang="ko-KR" sz="2800" b="1" dirty="0">
+                <a:solidFill>
+                  <a:srgbClr val="212529"/>
+                </a:solidFill>
+                <a:latin typeface="+mn-ea"/>
+              </a:rPr>
+              <a:t>]</a:t>
+            </a:r>
+            <a:r>
+              <a:rPr lang="en-US" altLang="ko-KR" sz="2800" dirty="0">
+                <a:solidFill>
+                  <a:srgbClr val="212529"/>
+                </a:solidFill>
+                <a:latin typeface="+mn-ea"/>
+              </a:rPr>
+              <a:t> </a:t>
+            </a:r>
+            <a:r>
+              <a:rPr lang="ko-KR" altLang="en-US" sz="2800" dirty="0">
+                <a:solidFill>
+                  <a:srgbClr val="212529"/>
+                </a:solidFill>
+                <a:latin typeface="+mn-ea"/>
+              </a:rPr>
+              <a:t>커리큘럼 클릭</a:t>
+            </a:r>
+            <a:endParaRPr lang="en-US" altLang="ko-KR" sz="2800" dirty="0">
+              <a:solidFill>
+                <a:srgbClr val="212529"/>
+              </a:solidFill>
+              <a:latin typeface="+mn-ea"/>
+            </a:endParaRPr>
+          </a:p>
+          <a:p>
+            <a:pPr lvl="1"/>
+            <a:r>
+              <a:rPr lang="ko-KR" altLang="en-US" sz="2800" b="1" dirty="0">
+                <a:solidFill>
+                  <a:srgbClr val="212529"/>
+                </a:solidFill>
+                <a:latin typeface="+mn-ea"/>
+              </a:rPr>
+              <a:t>➡ </a:t>
+            </a:r>
+            <a:r>
+              <a:rPr lang="en-US" altLang="ko-KR" sz="2800" b="1" dirty="0">
+                <a:solidFill>
+                  <a:schemeClr val="accent1"/>
+                </a:solidFill>
+                <a:latin typeface="+mn-ea"/>
+              </a:rPr>
+              <a:t>[1</a:t>
+            </a:r>
+            <a:r>
+              <a:rPr lang="ko-KR" altLang="en-US" sz="2800" b="1" dirty="0">
+                <a:solidFill>
+                  <a:schemeClr val="accent1"/>
+                </a:solidFill>
+                <a:latin typeface="+mn-ea"/>
+              </a:rPr>
+              <a:t>번 문제</a:t>
+            </a:r>
+            <a:r>
+              <a:rPr lang="en-US" altLang="ko-KR" sz="2800" b="1" dirty="0">
+                <a:solidFill>
+                  <a:schemeClr val="accent1"/>
+                </a:solidFill>
+                <a:latin typeface="+mn-ea"/>
+              </a:rPr>
+              <a:t>]</a:t>
+            </a:r>
+            <a:r>
+              <a:rPr lang="en-US" altLang="ko-KR" sz="2800" dirty="0">
+                <a:solidFill>
+                  <a:schemeClr val="accent1"/>
+                </a:solidFill>
+                <a:latin typeface="+mn-ea"/>
+              </a:rPr>
+              <a:t> </a:t>
+            </a:r>
+            <a:r>
+              <a:rPr lang="ko-KR" altLang="en-US" sz="2800" dirty="0">
+                <a:solidFill>
+                  <a:srgbClr val="212529"/>
+                </a:solidFill>
+                <a:latin typeface="+mn-ea"/>
+              </a:rPr>
+              <a:t> 진행</a:t>
+            </a:r>
+          </a:p>
+        </p:txBody>
+      </p:sp>
+    </p:spTree>
+    <p:extLst>
+      <p:ext uri="{BB962C8B-B14F-4D97-AF65-F5344CB8AC3E}">
+        <p14:creationId xmlns:p14="http://schemas.microsoft.com/office/powerpoint/2010/main" val="266258550"/>
       </p:ext>
     </p:extLst>
   </p:cSld>
@@ -5166,7 +5749,7 @@
           <a:p>
             <a:fld id="{0E19CB95-6D28-40F1-9DA3-1BAC5D4B5B4F}" type="datetime6">
               <a:rPr lang="ko-KR" altLang="en-US" smtClean="0"/>
-              <a:t>2023년 10월</a:t>
+              <a:t>2024년 8월</a:t>
             </a:fld>
             <a:endParaRPr lang="ko-KR" altLang="en-US"/>
           </a:p>
@@ -5730,7 +6313,12 @@
             <p:ph idx="1"/>
           </p:nvPr>
         </p:nvSpPr>
-        <p:spPr/>
+        <p:spPr>
+          <a:xfrm>
+            <a:off x="838200" y="1825625"/>
+            <a:ext cx="10134600" cy="4351338"/>
+          </a:xfrm>
+        </p:spPr>
         <p:txBody>
           <a:bodyPr/>
           <a:lstStyle/>
@@ -5741,15 +6329,7 @@
             </a:r>
             <a:r>
               <a:rPr lang="ko-KR" altLang="en-US" dirty="0"/>
-              <a:t>를 이용해서 데이터를 상위 </a:t>
-            </a:r>
-            <a:r>
-              <a:rPr lang="ko-KR" altLang="en-US" dirty="0" err="1"/>
-              <a:t>컴포넌트에게</a:t>
-            </a:r>
-            <a:r>
-              <a:rPr lang="ko-KR" altLang="en-US" dirty="0"/>
-              <a:t> 받을 때는 </a:t>
+              <a:t>를 이용해서 데이터를 상위 컴포넌트에게 받을 때는 </a:t>
             </a:r>
             <a:r>
               <a:rPr lang="en-US" altLang="ko-KR" dirty="0"/>
@@ -10439,7 +11019,7 @@
             <a:r>
               <a:rPr lang="en-US" altLang="ko-KR" sz="2000" dirty="0" err="1">
                 <a:solidFill>
-                  <a:srgbClr val="00CC66"/>
+                  <a:schemeClr val="accent5"/>
                 </a:solidFill>
               </a:rPr>
               <a:t>React.MouseEvent</a:t>
@@ -10493,7 +11073,7 @@
             <a:r>
               <a:rPr lang="en-US" altLang="ko-KR" sz="2000" dirty="0" err="1">
                 <a:solidFill>
-                  <a:srgbClr val="00CC66"/>
+                  <a:schemeClr val="accent5"/>
                 </a:solidFill>
               </a:rPr>
               <a:t>React.ChangeEvent</a:t>
@@ -10574,7 +11154,7 @@
             <a:r>
               <a:rPr lang="en-US" altLang="ko-KR" sz="2000" dirty="0" err="1">
                 <a:solidFill>
-                  <a:srgbClr val="00CC66"/>
+                  <a:schemeClr val="accent5"/>
                 </a:solidFill>
               </a:rPr>
               <a:t>React.KeyboardEvent</a:t>
@@ -10657,7 +11237,7 @@
 </file>
 
 <file path=ppt/theme/theme1.xml><?xml version="1.0" encoding="utf-8"?>
-<a:theme xmlns:a="http://schemas.openxmlformats.org/drawingml/2006/main" name="2_Office 테마">
+<a:theme xmlns:a="http://schemas.openxmlformats.org/drawingml/2006/main" name="3_Office 테마">
   <a:themeElements>
     <a:clrScheme name="코딩온_새싹">
       <a:dk1>
@@ -10697,15 +11277,15 @@
         <a:srgbClr val="954F72"/>
       </a:folHlink>
     </a:clrScheme>
-    <a:fontScheme name="코딩온">
+    <a:fontScheme name="Pretendard GOV">
       <a:majorFont>
-        <a:latin typeface="메이플스토리"/>
-        <a:ea typeface="메이플스토리"/>
+        <a:latin typeface="Pretendard GOV"/>
+        <a:ea typeface="Pretendard GOV"/>
         <a:cs typeface=""/>
       </a:majorFont>
       <a:minorFont>
-        <a:latin typeface="메이플스토리"/>
-        <a:ea typeface="메이플스토리"/>
+        <a:latin typeface="Pretendard GOV"/>
+        <a:ea typeface="Pretendard GOV"/>
         <a:cs typeface=""/>
       </a:minorFont>
     </a:fontScheme>

</xml_diff>